<commit_message>
Meeting 6/2 deck: revise with Nano4 partition constraints
- Budget slide now shows Nano4 dev (1 hr, single-GPU) vs normal (12 hr, 64 GPU min)
- Decision Q5 (258M) revised from 'skip' to 'DDP port worth it?' — Nano4 normal
  makes it technically viable in 1-2 days engineering + ~3 hr compute, but
  +4.2 pp value unchanged
- Priorities split 4-way: Taiwana-2/CPU | Nano4 dev | DDP port required | not doing
- Asks revised: Q1 confirm dev-only path, Q2 weigh DDP port for 258M
- Script updated with Nano4 hardware spec + DDP cost analysis Q&A
</commit_message>
<xml_diff>
--- a/docs/slides/meeting_2026_0602.pptx
+++ b/docs/slides/meeting_2026_0602.pptx
@@ -3710,7 +3710,7 @@
                   <a:srgbClr val="2E7D32"/>
                 </a:solidFill>
               </a:rPr>
-              <a:t>Migration plan: Nano4 takes over</a:t>
+              <a:t>Use Nano4 dev partition for our pipeline</a:t>
             </a:r>
           </a:p>
         </p:txBody>
@@ -3763,7 +3763,7 @@
                   <a:srgbClr val="0A2540"/>
                 </a:solidFill>
               </a:rPr>
-              <a:t>Confirm Nano4 (H200, free 1-month) replaces TWCC as primary GPU. DNABERT-2 resumes on Nano4. TWCC dormant. Speed benchmark on H200. OK?</a:t>
+              <a:t>Nano4 normal needs 64 GPU min (DDP-only). Plan: all our inference + DNABERT-2 resume go on dev (1-hr jobs, auto-resume). Speed benchmark / HMP / Per-genus realign all fit. OK?</a:t>
             </a:r>
           </a:p>
         </p:txBody>
@@ -3783,7 +3783,7 @@
             <a:avLst/>
           </a:prstGeom>
           <a:solidFill>
-            <a:srgbClr val="C62828"/>
+            <a:srgbClr val="E65100"/>
           </a:solidFill>
           <a:ln>
             <a:noFill/>
@@ -3845,10 +3845,10 @@
             <a:r>
               <a:rPr sz="1400" b="1">
                 <a:solidFill>
-                  <a:srgbClr val="C62828"/>
-                </a:solidFill>
-              </a:rPr>
-              <a:t>DNABERT-1 50M — final call</a:t>
+                  <a:srgbClr val="E65100"/>
+                </a:solidFill>
+              </a:rPr>
+              <a:t>258M training — DDP port worth it?</a:t>
             </a:r>
           </a:p>
         </p:txBody>
@@ -3872,7 +3872,7 @@
           </a:solidFill>
           <a:ln w="19050">
             <a:solidFill>
-              <a:srgbClr val="C62828"/>
+              <a:srgbClr val="E65100"/>
             </a:solidFill>
           </a:ln>
         </p:spPr>
@@ -3901,7 +3901,7 @@
                   <a:srgbClr val="0A2540"/>
                 </a:solidFill>
               </a:rPr>
-              <a:t>Cancel. Use 5M acc (61.78%) + 11.7 hr/epoch cost vs NT-v2's 2.8 hr as deployment-limitation evidence in thesis. Agreed?</a:t>
+              <a:t>Nano4 normal makes 258M technically viable: 1-2 days DDP port + few hours on 64 H200. Predicted gain: +4.2 pp (log-fit), does NOT cross tokenisation gap. Pursue or skip?</a:t>
             </a:r>
           </a:p>
         </p:txBody>
@@ -5904,7 +5904,7 @@
         <p:spPr>
           <a:xfrm>
             <a:off x="274320" y="1005840"/>
-            <a:ext cx="11612880" cy="4450974"/>
+            <a:ext cx="11612880" cy="5201602"/>
           </a:xfrm>
           <a:prstGeom prst="rect">
             <a:avLst/>
@@ -6150,7 +6150,7 @@
         <p:spPr>
           <a:xfrm>
             <a:off x="274320" y="914400"/>
-            <a:ext cx="11612880" cy="5428539"/>
+            <a:ext cx="11612880" cy="5425961"/>
           </a:xfrm>
           <a:prstGeom prst="rect">
             <a:avLst/>
@@ -6352,12 +6352,12 @@
           <a:p>
             <a:pPr algn="l"/>
             <a:r>
-              <a:rPr sz="1600" b="1">
+              <a:rPr sz="1500" b="1">
                 <a:solidFill>
                   <a:srgbClr val="2E7D32"/>
                 </a:solidFill>
               </a:rPr>
-              <a:t>Immediate (CPU / no GPU needed)</a:t>
+              <a:t>Now (Taiwana-2 / CPU — no Nano4 needed)</a:t>
             </a:r>
           </a:p>
         </p:txBody>
@@ -6371,7 +6371,7 @@
         <p:spPr>
           <a:xfrm>
             <a:off x="457200" y="1371600"/>
-            <a:ext cx="11247120" cy="1463040"/>
+            <a:ext cx="11247120" cy="1097280"/>
           </a:xfrm>
           <a:prstGeom prst="roundRect">
             <a:avLst/>
@@ -6405,45 +6405,34 @@
           <a:p>
             <a:pPr algn="l"/>
             <a:r>
-              <a:rPr sz="1200" b="0">
+              <a:rPr sz="1150" b="0">
                 <a:solidFill>
                   <a:srgbClr val="0A2540"/>
                 </a:solidFill>
               </a:rPr>
-              <a:t>• Realign Per-genus 13-mer (Exp F) on Taiwana-2 → integrate in-DB row of Table 4.30</a:t>
+              <a:t>• Realign Per-genus 13-mer (Exp F) on Taiwana-2 → integrate Table 4.30</a:t>
             </a:r>
           </a:p>
           <a:p>
             <a:pPr algn="l"/>
             <a:r>
-              <a:rPr sz="1200" b="0">
+              <a:rPr sz="1150" b="0">
                 <a:solidFill>
                   <a:srgbClr val="0A2540"/>
                 </a:solidFill>
               </a:rPr>
-              <a:t>• Thesis figure regeneration with new aligned MT numbers (53.7%, 94.25%)</a:t>
+              <a:t>• Thesis figure regeneration with aligned MT numbers (53.7%, 94.25%)</a:t>
             </a:r>
           </a:p>
           <a:p>
             <a:pPr algn="l"/>
             <a:r>
-              <a:rPr sz="1200" b="0">
+              <a:rPr sz="1150" b="0">
                 <a:solidFill>
                   <a:srgbClr val="0A2540"/>
                 </a:solidFill>
               </a:rPr>
-              <a:t>• Thesis Section 4.13 proofreading + format consistency check</a:t>
-            </a:r>
-          </a:p>
-          <a:p>
-            <a:pPr algn="l"/>
-            <a:r>
-              <a:rPr sz="1200" b="0">
-                <a:solidFill>
-                  <a:srgbClr val="0A2540"/>
-                </a:solidFill>
-              </a:rPr>
-              <a:t>• Optional: MT 13-mer hier retraining on Taiwana-2 (Q3)</a:t>
+              <a:t>• Section 4.13 proofreading + format check  ·  optional MT 13-mer hier retrain (Q3)</a:t>
             </a:r>
           </a:p>
         </p:txBody>
@@ -6456,7 +6445,7 @@
         </p:nvSpPr>
         <p:spPr>
           <a:xfrm>
-            <a:off x="457200" y="3017520"/>
+            <a:off x="457200" y="2651760"/>
             <a:ext cx="11247120" cy="457200"/>
           </a:xfrm>
           <a:prstGeom prst="rect">
@@ -6472,12 +6461,12 @@
           <a:p>
             <a:pPr algn="l"/>
             <a:r>
-              <a:rPr sz="1600" b="1">
-                <a:solidFill>
-                  <a:srgbClr val="B8860B"/>
-                </a:solidFill>
-              </a:rPr>
-              <a:t>After Nano4 sanity check unblocks (~45 GPU-hr on H200, FREE)</a:t>
+              <a:rPr sz="1500" b="1">
+                <a:solidFill>
+                  <a:srgbClr val="1E6091"/>
+                </a:solidFill>
+              </a:rPr>
+              <a:t>Fits Nano4 dev partition (1-hr jobs, single-GPU)</a:t>
             </a:r>
           </a:p>
         </p:txBody>
@@ -6490,8 +6479,128 @@
         </p:nvSpPr>
         <p:spPr>
           <a:xfrm>
-            <a:off x="457200" y="3474720"/>
+            <a:off x="457200" y="3108960"/>
             <a:ext cx="11247120" cy="1463040"/>
+          </a:xfrm>
+          <a:prstGeom prst="roundRect">
+            <a:avLst/>
+          </a:prstGeom>
+          <a:solidFill>
+            <a:srgbClr val="E3F2FD"/>
+          </a:solidFill>
+          <a:ln w="19050">
+            <a:solidFill>
+              <a:srgbClr val="1E6091"/>
+            </a:solidFill>
+          </a:ln>
+        </p:spPr>
+        <p:style>
+          <a:lnRef idx="1">
+            <a:schemeClr val="accent1"/>
+          </a:lnRef>
+          <a:fillRef idx="3">
+            <a:schemeClr val="accent1"/>
+          </a:fillRef>
+          <a:effectRef idx="2">
+            <a:schemeClr val="accent1"/>
+          </a:effectRef>
+          <a:fontRef idx="minor">
+            <a:schemeClr val="lt1"/>
+          </a:fontRef>
+        </p:style>
+        <p:txBody>
+          <a:bodyPr rtlCol="0" anchor="ctr" wrap="square" lIns="137160" rIns="137160" tIns="73152" bIns="73152"/>
+          <a:lstStyle/>
+          <a:p>
+            <a:pPr algn="l"/>
+            <a:r>
+              <a:rPr sz="1150" b="0">
+                <a:solidFill>
+                  <a:srgbClr val="0A2540"/>
+                </a:solidFill>
+              </a:rPr>
+              <a:t>• Sanity check NT-Species inference (BLOCKED — fix transformers==4.35.2 first)</a:t>
+            </a:r>
+          </a:p>
+          <a:p>
+            <a:pPr algn="l"/>
+            <a:r>
+              <a:rPr sz="1150" b="0">
+                <a:solidFill>
+                  <a:srgbClr val="0A2540"/>
+                </a:solidFill>
+              </a:rPr>
+              <a:t>• DNABERT-2 50M resume — 36 dev resubmits w/ auto-resume from last.pt (~3-4 days)</a:t>
+            </a:r>
+          </a:p>
+          <a:p>
+            <a:pPr algn="l"/>
+            <a:r>
+              <a:rPr sz="1150" b="0">
+                <a:solidFill>
+                  <a:srgbClr val="0A2540"/>
+                </a:solidFill>
+              </a:rPr>
+              <a:t>• Speed/memory unified benchmark on H200 (~30 min wall clock)</a:t>
+            </a:r>
+          </a:p>
+          <a:p>
+            <a:pPr algn="l"/>
+            <a:r>
+              <a:rPr sz="1150" b="0">
+                <a:solidFill>
+                  <a:srgbClr val="0A2540"/>
+                </a:solidFill>
+              </a:rPr>
+              <a:t>• HMP mock community real-dataset inference (~30 min) — paper prep</a:t>
+            </a:r>
+          </a:p>
+        </p:txBody>
+      </p:sp>
+      <p:sp>
+        <p:nvSpPr>
+          <p:cNvPr id="10" name="TextBox 9"/>
+          <p:cNvSpPr txBox="1"/>
+          <p:nvPr/>
+        </p:nvSpPr>
+        <p:spPr>
+          <a:xfrm>
+            <a:off x="457200" y="4754880"/>
+            <a:ext cx="11247120" cy="457200"/>
+          </a:xfrm>
+          <a:prstGeom prst="rect">
+            <a:avLst/>
+          </a:prstGeom>
+          <a:noFill/>
+        </p:spPr>
+        <p:txBody>
+          <a:bodyPr wrap="square" lIns="137160" rIns="137160" tIns="73152" bIns="73152">
+            <a:spAutoFit/>
+          </a:bodyPr>
+          <a:lstStyle/>
+          <a:p>
+            <a:pPr algn="l"/>
+            <a:r>
+              <a:rPr sz="1500" b="1">
+                <a:solidFill>
+                  <a:srgbClr val="B8860B"/>
+                </a:solidFill>
+              </a:rPr>
+              <a:t>Requires DDP port (1-2 days eng) for Nano4 normal partition</a:t>
+            </a:r>
+          </a:p>
+        </p:txBody>
+      </p:sp>
+      <p:sp>
+        <p:nvSpPr>
+          <p:cNvPr id="11" name="Rounded Rectangle 10"/>
+          <p:cNvSpPr/>
+          <p:nvPr/>
+        </p:nvSpPr>
+        <p:spPr>
+          <a:xfrm>
+            <a:off x="457200" y="5212080"/>
+            <a:ext cx="11247120" cy="914400"/>
           </a:xfrm>
           <a:prstGeom prst="roundRect">
             <a:avLst/>
@@ -6525,93 +6634,48 @@
           <a:p>
             <a:pPr algn="l"/>
             <a:r>
-              <a:rPr sz="1200" b="0">
+              <a:rPr sz="1150" b="0">
                 <a:solidFill>
                   <a:srgbClr val="0A2540"/>
                 </a:solidFill>
               </a:rPr>
-              <a:t>• Sync DNABERT-2 50M last.pt → resume training (36 hr H200 from epoch 17)</a:t>
+              <a:t>• 258M training (genus +species) — DDP code rewrite, then ~few hr on 64 H200.</a:t>
             </a:r>
           </a:p>
           <a:p>
             <a:pPr algn="l"/>
             <a:r>
-              <a:rPr sz="1200" b="0">
+              <a:rPr sz="1150" b="0">
                 <a:solidFill>
                   <a:srgbClr val="0A2540"/>
                 </a:solidFill>
               </a:rPr>
-              <a:t>• Migrate MT model checkpoints from Taiwana-2 → Nano4</a:t>
+              <a:t>  Value: log-fit predicts +4.2 pp, does NOT cross tokenisation gap (MT 13-mer 87.4%)</a:t>
             </a:r>
           </a:p>
           <a:p>
             <a:pPr algn="l"/>
             <a:r>
-              <a:rPr sz="1200" b="0">
+              <a:rPr sz="1150" b="0">
                 <a:solidFill>
                   <a:srgbClr val="0A2540"/>
                 </a:solidFill>
               </a:rPr>
-              <a:t>• Run speed/memory unified benchmark on H200 (3 hr) — must-do, advisor ask</a:t>
-            </a:r>
-          </a:p>
-          <a:p>
-            <a:pPr algn="l"/>
-            <a:r>
-              <a:rPr sz="1200" b="0">
-                <a:solidFill>
-                  <a:srgbClr val="0A2540"/>
-                </a:solidFill>
-              </a:rPr>
-              <a:t>• HMP mock community real-dataset inference (3 hr) — paper submission prep</a:t>
-            </a:r>
-          </a:p>
-        </p:txBody>
-      </p:sp>
-      <p:sp>
-        <p:nvSpPr>
-          <p:cNvPr id="10" name="TextBox 9"/>
-          <p:cNvSpPr txBox="1"/>
-          <p:nvPr/>
-        </p:nvSpPr>
-        <p:spPr>
-          <a:xfrm>
-            <a:off x="457200" y="5120640"/>
-            <a:ext cx="11247120" cy="457200"/>
-          </a:xfrm>
-          <a:prstGeom prst="rect">
-            <a:avLst/>
-          </a:prstGeom>
-          <a:noFill/>
-        </p:spPr>
-        <p:txBody>
-          <a:bodyPr wrap="square" lIns="137160" rIns="137160" tIns="73152" bIns="73152">
-            <a:spAutoFit/>
-          </a:bodyPr>
-          <a:lstStyle/>
-          <a:p>
-            <a:pPr algn="l"/>
-            <a:r>
-              <a:rPr sz="1600" b="1">
-                <a:solidFill>
-                  <a:srgbClr val="C62828"/>
-                </a:solidFill>
-              </a:rPr>
-              <a:t>Recommended NOT to do (advisor confirm if disagree)</a:t>
-            </a:r>
-          </a:p>
-        </p:txBody>
-      </p:sp>
-      <p:sp>
-        <p:nvSpPr>
-          <p:cNvPr id="11" name="Rounded Rectangle 10"/>
+              <a:t>  → Cost-benefit: 1-2 days engineering for marginal acc improvement</a:t>
+            </a:r>
+          </a:p>
+        </p:txBody>
+      </p:sp>
+      <p:sp>
+        <p:nvSpPr>
+          <p:cNvPr id="12" name="Rounded Rectangle 11"/>
           <p:cNvSpPr/>
           <p:nvPr/>
         </p:nvSpPr>
         <p:spPr>
           <a:xfrm>
-            <a:off x="457200" y="5577840"/>
-            <a:ext cx="11247120" cy="1005840"/>
+            <a:off x="457200" y="6263640"/>
+            <a:ext cx="11247120" cy="365760"/>
           </a:xfrm>
           <a:prstGeom prst="roundRect">
             <a:avLst/>
@@ -6645,23 +6709,12 @@
           <a:p>
             <a:pPr algn="l"/>
             <a:r>
-              <a:rPr sz="1200" b="0">
-                <a:solidFill>
-                  <a:srgbClr val="0A2540"/>
-                </a:solidFill>
-              </a:rPr>
-              <a:t>• DNABERT-1 50M continue: ~300 GPU-hr / 13 days — 5M evidence + 11.7 hr/epoch cost argument suffices</a:t>
-            </a:r>
-          </a:p>
-          <a:p>
-            <a:pPr algn="l"/>
-            <a:r>
-              <a:rPr sz="1200" b="0">
-                <a:solidFill>
-                  <a:srgbClr val="0A2540"/>
-                </a:solidFill>
-              </a:rPr>
-              <a:t>• 258M training: ~290 GPU-hr / 18 days — log-fit predicts +4.2 pp, does not cross tokenisation gap</a:t>
+              <a:rPr sz="1050" b="0">
+                <a:solidFill>
+                  <a:srgbClr val="C62828"/>
+                </a:solidFill>
+              </a:rPr>
+              <a:t>Not doing — DNABERT-1 50M (300 GPU-hr / 5× slower than DNABERT-2 — single dev partition impractical, ~10 weeks)</a:t>
             </a:r>
           </a:p>
         </p:txBody>

</xml_diff>